<commit_message>
Final Submission: CSE400_M1_Final_PPT.pdf and CSE400_M1_Final_PPT.pptx
</commit_message>
<xml_diff>
--- a/CSE400_M1_Final_PPT.pptx
+++ b/CSE400_M1_Final_PPT.pptx
@@ -4924,7 +4924,17 @@
                 <a:ea typeface="Roboto"/>
                 <a:cs typeface="Roboto"/>
               </a:rPr>
-              <a:t>Falak </a:t>
+              <a:t>Falak Shah AU2440014</a:t>
+            </a:r>
+          </a:p>
+          <a:p>
+            <a:r>
+              <a:rPr lang="en-US" b="0" dirty="0">
+                <a:latin typeface="Roboto"/>
+                <a:ea typeface="Roboto"/>
+                <a:cs typeface="Roboto"/>
+              </a:rPr>
+              <a:t>Ishani </a:t>
             </a:r>
             <a:r>
               <a:rPr lang="en-US" b="0">
@@ -4932,23 +4942,13 @@
                 <a:ea typeface="Roboto"/>
                 <a:cs typeface="Roboto"/>
               </a:rPr>
-              <a:t>Shah AU2440014</a:t>
+              <a:t>Prajapati AU2440176</a:t>
             </a:r>
             <a:endParaRPr lang="en-US" b="0" dirty="0">
               <a:latin typeface="Roboto"/>
               <a:ea typeface="Roboto"/>
               <a:cs typeface="Roboto"/>
             </a:endParaRPr>
-          </a:p>
-          <a:p>
-            <a:r>
-              <a:rPr lang="en-US" b="0" dirty="0">
-                <a:latin typeface="Roboto"/>
-                <a:ea typeface="Roboto"/>
-                <a:cs typeface="Roboto"/>
-              </a:rPr>
-              <a:t>Ishani Prajapati AU2440177</a:t>
-            </a:r>
           </a:p>
           <a:p>
             <a:r>

</xml_diff>